<commit_message>
PowerPoint templates: own cover and closing slide for each split part
- Part 2 of every split deck now opens with its own cover whose design differs
  from part 1, not just its text: mirrored layout plus a new palette or photo
  (AI violet, Brand Identity navy with another photo, Brat inverted to black,
  Tech Stack server photo, UX charcoal/yellow, Objectives navy).
  Objectives part 2 had no cover at all; Brand Identity part 2 replaces the
  section-title slide with a real cover.
- Every part ends with a closing «Баярлалаа» slide in that part's cover style
  (Brat and Objectives keep their own thank-you slide).
- Logos are never mirrored; Tech Stack title shortened so the laptop no longer
  covers it; previews re-rendered, cache version bumped.

Co-Authored-By: Claude Opus 5.5 <noreply@anthropic.com>
Claude-Session: https://claude.ai/code/session_0139ukJXmVJBeu9uBvasZqB2
</commit_message>
<xml_diff>
--- a/assets/pptx-tpl/brand-identity-1.pptx
+++ b/assets/pptx-tpl/brand-identity-1.pptx
@@ -17,6 +17,7 @@
     <p:sldId id="262" r:id="rId12"/>
     <p:sldId id="263" r:id="rId13"/>
     <p:sldId id="264" r:id="rId14"/>
+    <p:sldId id="276" r:id="rId39"/>
   </p:sldIdLst>
   <p:sldSz cy="6858000" cx="12192000"/>
   <p:notesSz cx="6858000" cy="9144000"/>
@@ -13364,6 +13365,605 @@
 </p:sld>
 </file>
 
+<file path=ppt/slides/slide21.xml><?xml version="1.0" encoding="utf-8"?>
+<p:sld xmlns:a="http://schemas.openxmlformats.org/drawingml/2006/main" xmlns:r="http://schemas.openxmlformats.org/officeDocument/2006/relationships" xmlns:mc="http://schemas.openxmlformats.org/markup-compatibility/2006" xmlns:mv="urn:schemas-microsoft-com:mac:vml" xmlns:p="http://schemas.openxmlformats.org/presentationml/2006/main" xmlns:c="http://schemas.openxmlformats.org/drawingml/2006/chart" xmlns:dgm="http://schemas.openxmlformats.org/drawingml/2006/diagram" xmlns:o="urn:schemas-microsoft-com:office:office" xmlns:v="urn:schemas-microsoft-com:vml" xmlns:pvml="urn:schemas-microsoft-com:office:powerpoint" xmlns:com="http://schemas.openxmlformats.org/drawingml/2006/compatibility" xmlns:p14="http://schemas.microsoft.com/office/powerpoint/2010/main" xmlns:p15="http://schemas.microsoft.com/office/powerpoint/2012/main" xmlns:ahyp="http://schemas.microsoft.com/office/drawing/2018/hyperlinkcolor">
+  <p:cSld>
+    <p:bg>
+      <p:bgPr>
+        <a:solidFill>
+          <a:schemeClr val="lt1"/>
+        </a:solidFill>
+      </p:bgPr>
+    </p:bg>
+    <p:spTree>
+      <p:nvGrpSpPr>
+        <p:cNvPr id="88" name="Shape 88"/>
+        <p:cNvGrpSpPr/>
+        <p:nvPr/>
+      </p:nvGrpSpPr>
+      <p:grpSpPr>
+        <a:xfrm>
+          <a:off x="0" y="0"/>
+          <a:ext cx="0" cy="0"/>
+          <a:chOff x="0" y="0"/>
+          <a:chExt cx="0" cy="0"/>
+        </a:xfrm>
+      </p:grpSpPr>
+      <p:sp>
+        <p:nvSpPr>
+          <p:cNvPr id="89" name="Google Shape;89;p1"/>
+          <p:cNvSpPr/>
+          <p:nvPr/>
+        </p:nvSpPr>
+        <p:spPr>
+          <a:xfrm>
+            <a:off x="0" y="-2"/>
+            <a:ext cx="8768851" cy="5715002"/>
+          </a:xfrm>
+          <a:prstGeom prst="rect">
+            <a:avLst/>
+          </a:prstGeom>
+          <a:solidFill>
+            <a:srgbClr val="2856AE"/>
+          </a:solidFill>
+          <a:ln>
+            <a:noFill/>
+          </a:ln>
+        </p:spPr>
+        <p:txBody>
+          <a:bodyPr anchorCtr="0" anchor="ctr" bIns="45700" lIns="91425" spcFirstLastPara="1" rIns="91425" wrap="square" tIns="45700">
+            <a:noAutofit/>
+          </a:bodyPr>
+          <a:lstStyle/>
+          <a:p>
+            <a:pPr indent="0" lvl="0" marL="0" marR="0" rtl="0" algn="ctr">
+              <a:spcBef>
+                <a:spcPts val="0"/>
+              </a:spcBef>
+              <a:spcAft>
+                <a:spcPts val="0"/>
+              </a:spcAft>
+              <a:buNone/>
+            </a:pPr>
+            <a:r>
+              <a:t/>
+            </a:r>
+            <a:endParaRPr b="0" i="0" sz="1800" u="none" cap="none" strike="noStrike">
+              <a:solidFill>
+                <a:schemeClr val="lt1"/>
+              </a:solidFill>
+              <a:latin typeface="Arial"/>
+              <a:ea typeface="Arial"/>
+              <a:cs typeface="Arial"/>
+              <a:sym typeface="Arial"/>
+            </a:endParaRPr>
+          </a:p>
+        </p:txBody>
+      </p:sp>
+      <p:sp>
+        <p:nvSpPr>
+          <p:cNvPr id="90" name="Google Shape;90;p1"/>
+          <p:cNvSpPr txBox="1"/>
+          <p:nvPr/>
+        </p:nvSpPr>
+        <p:spPr>
+          <a:xfrm>
+            <a:off x="1300484" y="2309564"/>
+            <a:ext cx="6944356" cy="2954655"/>
+          </a:xfrm>
+          <a:prstGeom prst="rect">
+            <a:avLst/>
+          </a:prstGeom>
+          <a:noFill/>
+          <a:ln>
+            <a:noFill/>
+          </a:ln>
+        </p:spPr>
+        <p:txBody>
+          <a:bodyPr anchorCtr="0" anchor="b" bIns="0" lIns="0" spcFirstLastPara="1" rIns="0" wrap="square" tIns="0">
+            <a:spAutoFit/>
+          </a:bodyPr>
+          <a:lstStyle/>
+          <a:p>
+            <a:pPr indent="0" lvl="0" marL="0" marR="0" rtl="0" algn="l">
+              <a:lnSpc>
+                <a:spcPct val="80000"/>
+              </a:lnSpc>
+              <a:spcBef>
+                <a:spcPts val="0"/>
+              </a:spcBef>
+              <a:spcAft>
+                <a:spcPts val="0"/>
+              </a:spcAft>
+              <a:buNone/>
+            </a:pPr>
+            <a:r>
+              <a:rPr b="1" i="0" lang="mn-MN" sz="8000" u="none" cap="none" strike="noStrike">
+                <a:solidFill>
+                  <a:schemeClr val="lt1"/>
+                </a:solidFill>
+                <a:latin typeface="Playfair Display"/>
+                <a:ea typeface="Playfair Display"/>
+                <a:cs typeface="Playfair Display"/>
+                <a:sym typeface="Playfair Display"/>
+              </a:rPr>
+              <a:t>Баярлалаа</a:t>
+            </a:r>
+            <a:endParaRPr/>
+          </a:p>
+          <a:p>
+            <a:pPr indent="0" lvl="0" marL="0" marR="0" rtl="0" algn="l">
+              <a:lnSpc>
+                <a:spcPct val="80000"/>
+              </a:lnSpc>
+              <a:spcBef>
+                <a:spcPts val="0"/>
+              </a:spcBef>
+              <a:spcAft>
+                <a:spcPts val="0"/>
+              </a:spcAft>
+              <a:buNone/>
+            </a:pPr>
+            <a:r>
+              <a:rPr b="1" i="0" lang="mn-MN" sz="8000" u="none" cap="none" strike="noStrike">
+                <a:solidFill>
+                  <a:schemeClr val="lt1"/>
+                </a:solidFill>
+                <a:latin typeface="Playfair Display"/>
+                <a:ea typeface="Playfair Display"/>
+                <a:cs typeface="Playfair Display"/>
+                <a:sym typeface="Playfair Display"/>
+              </a:rPr>
+              <a:t> </a:t>
+            </a:r>
+            <a:endParaRPr b="0" i="0" sz="8000" u="none" cap="none" strike="noStrike">
+              <a:solidFill>
+                <a:schemeClr val="lt1"/>
+              </a:solidFill>
+              <a:latin typeface="Playfair Display"/>
+              <a:ea typeface="Playfair Display"/>
+              <a:cs typeface="Playfair Display"/>
+              <a:sym typeface="Playfair Display"/>
+            </a:endParaRPr>
+          </a:p>
+        </p:txBody>
+      </p:sp>
+      <p:grpSp>
+        <p:nvGrpSpPr>
+          <p:cNvPr id="91" name="Google Shape;91;p1"/>
+          <p:cNvGrpSpPr/>
+          <p:nvPr/>
+        </p:nvGrpSpPr>
+        <p:grpSpPr>
+          <a:xfrm rot="10800000">
+            <a:off x="226350" y="272425"/>
+            <a:ext cx="153900" cy="4904824"/>
+            <a:chOff x="226311" y="1566109"/>
+            <a:chExt cx="153900" cy="4904824"/>
+          </a:xfrm>
+        </p:grpSpPr>
+        <p:sp>
+          <p:nvSpPr>
+            <p:cNvPr id="92" name="Google Shape;92;p1"/>
+            <p:cNvSpPr txBox="1"/>
+            <p:nvPr/>
+          </p:nvSpPr>
+          <p:spPr>
+            <a:xfrm rot="5400000">
+              <a:off x="-423339" y="2215759"/>
+              <a:ext cx="1453200" cy="153900"/>
+            </a:xfrm>
+            <a:prstGeom prst="rect">
+              <a:avLst/>
+            </a:prstGeom>
+            <a:noFill/>
+            <a:ln>
+              <a:noFill/>
+            </a:ln>
+          </p:spPr>
+          <p:txBody>
+            <a:bodyPr anchorCtr="0" anchor="ctr" bIns="0" lIns="0" spcFirstLastPara="1" rIns="108000" wrap="square" tIns="0">
+              <a:spAutoFit/>
+            </a:bodyPr>
+            <a:lstStyle/>
+            <a:p>
+              <a:pPr indent="0" lvl="0" marL="0" marR="0" rtl="0" algn="ctr">
+                <a:spcBef>
+                  <a:spcPts val="0"/>
+                </a:spcBef>
+                <a:spcAft>
+                  <a:spcPts val="0"/>
+                </a:spcAft>
+                <a:buNone/>
+              </a:pPr>
+              <a:r>
+                <a:rPr b="0" i="0" lang="mn-MN" sz="1000" u="none" cap="none" strike="noStrike">
+                  <a:solidFill>
+                    <a:schemeClr val="lt1"/>
+                  </a:solidFill>
+                  <a:latin typeface="Roboto"/>
+                  <a:ea typeface="Roboto"/>
+                  <a:cs typeface="Roboto"/>
+                  <a:sym typeface="Roboto"/>
+                </a:rPr>
+                <a:t>graphican.online</a:t>
+              </a:r>
+              <a:endParaRPr/>
+            </a:p>
+          </p:txBody>
+        </p:sp>
+        <p:sp>
+          <p:nvSpPr>
+            <p:cNvPr id="93" name="Google Shape;93;p1"/>
+            <p:cNvSpPr txBox="1"/>
+            <p:nvPr/>
+          </p:nvSpPr>
+          <p:spPr>
+            <a:xfrm rot="5400000">
+              <a:off x="-345214" y="5753183"/>
+              <a:ext cx="1296900" cy="138600"/>
+            </a:xfrm>
+            <a:prstGeom prst="rect">
+              <a:avLst/>
+            </a:prstGeom>
+            <a:noFill/>
+            <a:ln>
+              <a:noFill/>
+            </a:ln>
+          </p:spPr>
+          <p:txBody>
+            <a:bodyPr anchorCtr="0" anchor="ctr" bIns="0" lIns="0" spcFirstLastPara="1" rIns="108000" wrap="square" tIns="0">
+              <a:spAutoFit/>
+            </a:bodyPr>
+            <a:lstStyle/>
+            <a:p>
+              <a:pPr indent="0" lvl="0" marL="0" marR="0" rtl="0" algn="r">
+                <a:spcBef>
+                  <a:spcPts val="0"/>
+                </a:spcBef>
+                <a:spcAft>
+                  <a:spcPts val="0"/>
+                </a:spcAft>
+                <a:buNone/>
+              </a:pPr>
+              <a:r>
+                <a:rPr b="1" i="0" lang="mn-MN" sz="900" u="none" cap="none" strike="noStrike">
+                  <a:solidFill>
+                    <a:schemeClr val="lt1"/>
+                  </a:solidFill>
+                  <a:latin typeface="Roboto"/>
+                  <a:ea typeface="Roboto"/>
+                  <a:cs typeface="Roboto"/>
+                  <a:sym typeface="Roboto"/>
+                </a:rPr>
+                <a:t>Брэнд</a:t>
+              </a:r>
+              <a:r>
+                <a:rPr b="0" i="0" lang="mn-MN" sz="900" u="none" cap="none" strike="noStrike">
+                  <a:solidFill>
+                    <a:schemeClr val="lt1"/>
+                  </a:solidFill>
+                  <a:latin typeface="Roboto"/>
+                  <a:ea typeface="Roboto"/>
+                  <a:cs typeface="Roboto"/>
+                  <a:sym typeface="Roboto"/>
+                </a:rPr>
+                <a:t> · Огноо, он</a:t>
+              </a:r>
+              <a:endParaRPr/>
+            </a:p>
+          </p:txBody>
+        </p:sp>
+      </p:grpSp>
+      <p:cxnSp>
+        <p:nvCxnSpPr>
+          <p:cNvPr id="94" name="Google Shape;94;p1"/>
+          <p:cNvCxnSpPr/>
+          <p:nvPr/>
+        </p:nvCxnSpPr>
+        <p:spPr>
+          <a:xfrm>
+            <a:off x="650241" y="0"/>
+            <a:ext cx="0" cy="5693068"/>
+          </a:xfrm>
+          <a:prstGeom prst="straightConnector1">
+            <a:avLst/>
+          </a:prstGeom>
+          <a:noFill/>
+          <a:ln cap="flat" cmpd="sng" w="9525">
+            <a:solidFill>
+              <a:schemeClr val="lt1"/>
+            </a:solidFill>
+            <a:prstDash val="solid"/>
+            <a:miter lim="800000"/>
+            <a:headEnd len="sm" w="sm" type="none"/>
+            <a:tailEnd len="sm" w="sm" type="none"/>
+          </a:ln>
+        </p:spPr>
+      </p:cxnSp>
+      <p:pic>
+        <p:nvPicPr>
+          <p:cNvPr descr="A person using a tablet and a stylus&#10;&#10;Description automatically generated" id="95" name="Google Shape;95;p1"/>
+          <p:cNvPicPr preferRelativeResize="0"/>
+          <p:nvPr/>
+        </p:nvPicPr>
+        <p:blipFill rotWithShape="1">
+          <a:blip r:embed="rId3">
+            <a:alphaModFix/>
+          </a:blip>
+          <a:srcRect b="0" l="39512" r="27166" t="0"/>
+          <a:stretch/>
+        </p:blipFill>
+        <p:spPr>
+          <a:xfrm>
+            <a:off x="8768851" y="0"/>
+            <a:ext cx="3423149" cy="6858000"/>
+          </a:xfrm>
+          <a:prstGeom prst="rect">
+            <a:avLst/>
+          </a:prstGeom>
+          <a:noFill/>
+          <a:ln>
+            <a:noFill/>
+          </a:ln>
+        </p:spPr>
+      </p:pic>
+      <p:cxnSp>
+        <p:nvCxnSpPr>
+          <p:cNvPr id="96" name="Google Shape;96;p1"/>
+          <p:cNvCxnSpPr/>
+          <p:nvPr/>
+        </p:nvCxnSpPr>
+        <p:spPr>
+          <a:xfrm rot="10800000">
+            <a:off x="650241" y="675080"/>
+            <a:ext cx="8118610" cy="0"/>
+          </a:xfrm>
+          <a:prstGeom prst="straightConnector1">
+            <a:avLst/>
+          </a:prstGeom>
+          <a:noFill/>
+          <a:ln cap="flat" cmpd="sng" w="9525">
+            <a:solidFill>
+              <a:schemeClr val="lt1"/>
+            </a:solidFill>
+            <a:prstDash val="solid"/>
+            <a:miter lim="800000"/>
+            <a:headEnd len="sm" w="sm" type="none"/>
+            <a:tailEnd len="sm" w="sm" type="none"/>
+          </a:ln>
+        </p:spPr>
+      </p:cxnSp>
+      <p:grpSp>
+        <p:nvGrpSpPr>
+          <p:cNvPr id="97" name="Google Shape;97;p1"/>
+          <p:cNvGrpSpPr/>
+          <p:nvPr/>
+        </p:nvGrpSpPr>
+        <p:grpSpPr>
+          <a:xfrm>
+            <a:off x="443107" y="5993879"/>
+            <a:ext cx="2001644" cy="592067"/>
+            <a:chOff x="443107" y="5993879"/>
+            <a:chExt cx="2001644" cy="592067"/>
+          </a:xfrm>
+        </p:grpSpPr>
+        <p:grpSp>
+          <p:nvGrpSpPr>
+            <p:cNvPr id="98" name="Google Shape;98;p1"/>
+            <p:cNvGrpSpPr/>
+            <p:nvPr/>
+          </p:nvGrpSpPr>
+          <p:grpSpPr>
+            <a:xfrm>
+              <a:off x="1217935" y="5993879"/>
+              <a:ext cx="1226816" cy="566561"/>
+              <a:chOff x="-1293772" y="3311898"/>
+              <a:chExt cx="1809003" cy="667349"/>
+            </a:xfrm>
+          </p:grpSpPr>
+          <p:sp>
+            <p:nvSpPr>
+              <p:cNvPr id="99" name="Google Shape;99;p1"/>
+              <p:cNvSpPr txBox="1"/>
+              <p:nvPr/>
+            </p:nvSpPr>
+            <p:spPr>
+              <a:xfrm>
+                <a:off x="-1293772" y="3311898"/>
+                <a:ext cx="1809003" cy="507539"/>
+              </a:xfrm>
+              <a:prstGeom prst="rect">
+                <a:avLst/>
+              </a:prstGeom>
+              <a:noFill/>
+              <a:ln>
+                <a:noFill/>
+              </a:ln>
+            </p:spPr>
+            <p:txBody>
+              <a:bodyPr anchorCtr="0" anchor="t" bIns="0" lIns="0" spcFirstLastPara="1" rIns="0" wrap="square" tIns="0">
+                <a:spAutoFit/>
+              </a:bodyPr>
+              <a:lstStyle/>
+              <a:p>
+                <a:pPr indent="0" lvl="0" marL="0" marR="0" rtl="0" algn="l">
+                  <a:spcBef>
+                    <a:spcPts val="0"/>
+                  </a:spcBef>
+                  <a:spcAft>
+                    <a:spcPts val="0"/>
+                  </a:spcAft>
+                  <a:buNone/>
+                </a:pPr>
+                <a:r>
+                  <a:rPr b="1" i="0" lang="mn-MN" sz="2800" u="none" cap="none" strike="noStrike">
+                    <a:solidFill>
+                      <a:srgbClr val="1E2860"/>
+                    </a:solidFill>
+                    <a:latin typeface="Roboto"/>
+                    <a:ea typeface="Roboto"/>
+                    <a:cs typeface="Roboto"/>
+                    <a:sym typeface="Roboto"/>
+                  </a:rPr>
+                  <a:t>БРЭНД</a:t>
+                </a:r>
+                <a:endParaRPr/>
+              </a:p>
+            </p:txBody>
+          </p:sp>
+          <p:sp>
+            <p:nvSpPr>
+              <p:cNvPr id="100" name="Google Shape;100;p1"/>
+              <p:cNvSpPr txBox="1"/>
+              <p:nvPr/>
+            </p:nvSpPr>
+            <p:spPr>
+              <a:xfrm>
+                <a:off x="-1293772" y="3779857"/>
+                <a:ext cx="1809003" cy="199390"/>
+              </a:xfrm>
+              <a:prstGeom prst="rect">
+                <a:avLst/>
+              </a:prstGeom>
+              <a:noFill/>
+              <a:ln>
+                <a:noFill/>
+              </a:ln>
+            </p:spPr>
+            <p:txBody>
+              <a:bodyPr anchorCtr="0" anchor="t" bIns="0" lIns="0" spcFirstLastPara="1" rIns="0" wrap="square" tIns="0">
+                <a:spAutoFit/>
+              </a:bodyPr>
+              <a:lstStyle/>
+              <a:p>
+                <a:pPr indent="0" lvl="0" marL="0" marR="0" rtl="0" algn="l">
+                  <a:spcBef>
+                    <a:spcPts val="0"/>
+                  </a:spcBef>
+                  <a:spcAft>
+                    <a:spcPts val="0"/>
+                  </a:spcAft>
+                  <a:buNone/>
+                </a:pPr>
+                <a:r>
+                  <a:rPr lang="mn-MN" sz="1100">
+                    <a:solidFill>
+                      <a:srgbClr val="1E2860"/>
+                    </a:solidFill>
+                    <a:latin typeface="Roboto"/>
+                    <a:ea typeface="Roboto"/>
+                    <a:cs typeface="Roboto"/>
+                    <a:sym typeface="Roboto"/>
+                  </a:rPr>
+                  <a:t>КОМПАНИ</a:t>
+                </a:r>
+                <a:endParaRPr/>
+              </a:p>
+            </p:txBody>
+          </p:sp>
+        </p:grpSp>
+        <p:grpSp>
+          <p:nvGrpSpPr>
+            <p:cNvPr id="101" name="Google Shape;101;p1"/>
+            <p:cNvGrpSpPr/>
+            <p:nvPr/>
+          </p:nvGrpSpPr>
+          <p:grpSpPr>
+            <a:xfrm>
+              <a:off x="443107" y="5993879"/>
+              <a:ext cx="592067" cy="592067"/>
+              <a:chOff x="8187153" y="1492771"/>
+              <a:chExt cx="1358189" cy="1358189"/>
+            </a:xfrm>
+          </p:grpSpPr>
+          <p:sp>
+            <p:nvSpPr>
+              <p:cNvPr id="102" name="Google Shape;102;p1"/>
+              <p:cNvSpPr/>
+              <p:nvPr/>
+            </p:nvSpPr>
+            <p:spPr>
+              <a:xfrm>
+                <a:off x="8187153" y="1492771"/>
+                <a:ext cx="1358189" cy="1358189"/>
+              </a:xfrm>
+              <a:prstGeom prst="ellipse">
+                <a:avLst/>
+              </a:prstGeom>
+              <a:solidFill>
+                <a:srgbClr val="2856AE"/>
+              </a:solidFill>
+              <a:ln>
+                <a:noFill/>
+              </a:ln>
+            </p:spPr>
+            <p:txBody>
+              <a:bodyPr anchorCtr="0" anchor="ctr" bIns="45700" lIns="91425" spcFirstLastPara="1" rIns="91425" wrap="square" tIns="45700">
+                <a:noAutofit/>
+              </a:bodyPr>
+              <a:lstStyle/>
+              <a:p>
+                <a:pPr indent="0" lvl="0" marL="0" marR="0" rtl="0" algn="ctr">
+                  <a:spcBef>
+                    <a:spcPts val="0"/>
+                  </a:spcBef>
+                  <a:spcAft>
+                    <a:spcPts val="0"/>
+                  </a:spcAft>
+                  <a:buNone/>
+                </a:pPr>
+                <a:r>
+                  <a:t/>
+                </a:r>
+                <a:endParaRPr sz="1800">
+                  <a:solidFill>
+                    <a:schemeClr val="lt1"/>
+                  </a:solidFill>
+                  <a:latin typeface="Arial"/>
+                  <a:ea typeface="Arial"/>
+                  <a:cs typeface="Arial"/>
+                  <a:sym typeface="Arial"/>
+                </a:endParaRPr>
+              </a:p>
+            </p:txBody>
+          </p:sp>
+          <p:pic>
+            <p:nvPicPr>
+              <p:cNvPr id="103" name="Google Shape;103;p1"/>
+              <p:cNvPicPr preferRelativeResize="0"/>
+              <p:nvPr/>
+            </p:nvPicPr>
+            <p:blipFill rotWithShape="1">
+              <a:blip r:embed="rIdGc1">
+                <a:alphaModFix/>
+              </a:blip>
+              <a:stretch/>
+            </p:blipFill>
+            <p:spPr>
+              <a:xfrm>
+                <a:off x="8374326" y="1679944"/>
+                <a:ext cx="983842" cy="983842"/>
+              </a:xfrm>
+              <a:prstGeom prst="rect">
+                <a:avLst/>
+              </a:prstGeom>
+              <a:noFill/>
+              <a:ln>
+                <a:noFill/>
+              </a:ln>
+            </p:spPr>
+          </p:pic>
+        </p:grpSp>
+      </p:grpSp>
+    </p:spTree>
+  </p:cSld>
+  <p:clrMapOvr>
+    <a:masterClrMapping/>
+  </p:clrMapOvr>
+</p:sld>
+</file>
+
 <file path=ppt/slides/slide3.xml><?xml version="1.0" encoding="utf-8"?>
 <p:sld xmlns:a="http://schemas.openxmlformats.org/drawingml/2006/main" xmlns:r="http://schemas.openxmlformats.org/officeDocument/2006/relationships" xmlns:mc="http://schemas.openxmlformats.org/markup-compatibility/2006" xmlns:mv="urn:schemas-microsoft-com:mac:vml" xmlns:p="http://schemas.openxmlformats.org/presentationml/2006/main" xmlns:c="http://schemas.openxmlformats.org/drawingml/2006/chart" xmlns:dgm="http://schemas.openxmlformats.org/drawingml/2006/diagram" xmlns:o="urn:schemas-microsoft-com:office:office" xmlns:v="urn:schemas-microsoft-com:vml" xmlns:pvml="urn:schemas-microsoft-com:office:powerpoint" xmlns:com="http://schemas.openxmlformats.org/drawingml/2006/compatibility" xmlns:p14="http://schemas.microsoft.com/office/powerpoint/2010/main" xmlns:p15="http://schemas.microsoft.com/office/powerpoint/2012/main" xmlns:ahyp="http://schemas.microsoft.com/office/drawing/2018/hyperlinkcolor">
   <p:cSld>

</xml_diff>